<commit_message>
Revert "paper: propagate the Compile or Retire retitle to every build and doc"
This reverts commit e5149522c9f89a160de163750c6a9b62ed730ca7.
</commit_message>
<xml_diff>
--- a/paper/slides/compiling-recurrent-agent-workflows-into-guarded-programs-detailed.pptx
+++ b/paper/slides/compiling-recurrent-agent-workflows-into-guarded-programs-detailed.pptx
@@ -4170,7 +4170,7 @@
                 <a:ea typeface="Cambria"/>
                 <a:cs typeface="Cambria"/>
               </a:rPr>
-              <a:t>Compile or Retire: Evidence-Gated Specialization of Recurrent Agent Workflows</a:t>
+              <a:t>From Traces to Guarded Programs: Evidence-Gated Compilation of Recurrent Agent Workflows</a:t>
             </a:r>
           </a:p>
         </p:txBody>
@@ -28290,7 +28290,7 @@
                 <a:ea typeface="Calibri"/>
                 <a:cs typeface="Calibri"/>
               </a:rPr>
-              <a:t>Compile or Retire: Evidence-Gated Specialization of Recurrent Agent Workflows  ·  artifact includes pinned data snapshots, raw results, and an adversarial self-review</a:t>
+              <a:t>From Traces to Guarded Programs: Evidence-Gated Compilation of Recurrent Agent Workflows  ·  artifact includes pinned data snapshots, raw results, and an adversarial self-review</a:t>
             </a:r>
           </a:p>
         </p:txBody>

</xml_diff>

<commit_message>
slides: align the new results slides with the merged #72/#73 numbers
Rebuild the deck from main's original with the refresh script updated to
the all-scheduled BIRD accounting (402 vs 403 of 630, -45.8% requests on
629 completed pairs, 95% interval -3.3 to +3.0 points, equivalence not
established) and the retired 184-group end-to-end issue gate. Refresh the
slide record digest and change notes, and refinalize the manifest.

Co-Authored-By: Claude Opus 5.5 <noreply@anthropic.com>
</commit_message>
<xml_diff>
--- a/paper/slides/compiling-recurrent-agent-workflows-into-guarded-programs-detailed.pptx
+++ b/paper/slides/compiling-recurrent-agent-workflows-into-guarded-programs-detailed.pptx
@@ -3199,7 +3199,7 @@
           <a:lstStyle xmlns:a="http://schemas.openxmlformats.org/drawingml/2006/main"/>
           <a:p xmlns:a="http://schemas.openxmlformats.org/drawingml/2006/main">
             <a:r>
-              <a:t>BIRD is the public benchmark where GAC delivers a measured benefit. A schema-first SQL agent's opening (list the tables, read every schema) compiles on 26 of 31 databases with gpt-5.6-luna and on all five dev databases with gpt-6-luna; on 924 held-out questions there is no detected accuracy loss and model calls fall 45 to 50 percent. A standard agent that picks tables per question is refused everywhere, as is Claude Sonnet, which did not follow the schema-first instruction as a fixed step. Cost savings are modest (11 to 18 percent at uncached prices) because the removed calls are the shortest ones.</a:t>
+              <a:t>BIRD is the public benchmark where GAC delivers a measured benefit. A schema-first SQL agent's opening (list the tables, read every schema) compiles on 26 of 31 databases with gpt-5.6-luna and on all five dev databases with gpt-6-luna; on 930 scheduled held-out questions there is no detected accuracy loss (equivalence is not established) and model calls fall 45 to 50 percent. A standard agent that picks tables per question is refused everywhere, as is Claude Sonnet, which did not follow the schema-first instruction as a fixed step. Cost savings are modest (11 to 18 percent at uncached prices) because the removed calls are the shortest ones.</a:t>
             </a:r>
           </a:p>
         </p:txBody>
@@ -4628,7 +4628,7 @@
                 <a:ea typeface="Calibri"/>
                 <a:cs typeface="Calibri"/>
               </a:rPr>
-              <a:t>of 31 BIRD databases compiled, accuracy held</a:t>
+              <a:t>of 31 BIRD databases compiled; no loss detected</a:t>
             </a:r>
           </a:p>
         </p:txBody>
@@ -17863,7 +17863,7 @@
                 <a:ea typeface="Cambria"/>
                 <a:cs typeface="Cambria"/>
               </a:rPr>
-              <a:t>−45.9%</a:t>
+              <a:t>−45.8%</a:t>
             </a:r>
           </a:p>
         </p:txBody>
@@ -26318,7 +26318,7 @@
                 <a:ea typeface="Calibri"/>
                 <a:cs typeface="Calibri"/>
               </a:rPr>
-              <a:t>Every threshold below 0.14 admits nothing and every one above admits all 92, with zero violations. A pre-registered support-only comparator on four repositories and 240 held-out pairs found the same all-or-none step: still not a risk–coverage frontier.</a:t>
+              <a:t>Every threshold below 0.14 admits nothing and every one above admits all 92. A support-only comparator on 240 held-out pairs found the same step, and an amended 184-group end-to-end issue gate retired with two errors: no risk–coverage frontier.</a:t>
             </a:r>
           </a:p>
         </p:txBody>
@@ -28894,7 +28894,7 @@
                 <a:ea typeface="Cambria"/>
                 <a:cs typeface="Cambria"/>
               </a:rPr>
-              <a:t>−45.9%</a:t>
+              <a:t>−45.8%</a:t>
             </a:r>
           </a:p>
         </p:txBody>
@@ -28939,7 +28939,7 @@
                 <a:ea typeface="Calibri"/>
                 <a:cs typeface="Calibri"/>
               </a:rPr>
-              <a:t>provider requests, 625 held-out questions</a:t>
+              <a:t>provider requests, 629 completed pairs</a:t>
             </a:r>
           </a:p>
         </p:txBody>
@@ -28984,7 +28984,7 @@
                 <a:ea typeface="Cambria"/>
                 <a:cs typeface="Cambria"/>
               </a:rPr>
-              <a:t>−18.1%</a:t>
+              <a:t>402 / 403</a:t>
             </a:r>
           </a:p>
         </p:txBody>
@@ -29029,7 +29029,7 @@
                 <a:ea typeface="Calibri"/>
                 <a:cs typeface="Calibri"/>
               </a:rPr>
-              <a:t>estimated cost (−14.0% at uncached prices)</a:t>
+              <a:t>correct of 630, compiled vs. unchanged</a:t>
             </a:r>
           </a:p>
         </p:txBody>
@@ -29074,7 +29074,7 @@
                 <a:ea typeface="Cambria"/>
                 <a:cs typeface="Cambria"/>
               </a:rPr>
-              <a:t>400 / 401</a:t>
+              <a:t>−3.3 to +3.0</a:t>
             </a:r>
           </a:p>
         </p:txBody>
@@ -29119,7 +29119,7 @@
                 <a:ea typeface="Calibri"/>
                 <a:cs typeface="Calibri"/>
               </a:rPr>
-              <a:t>correct, compiled vs. unchanged agent</a:t>
+              <a:t>accuracy difference, 95% interval (points)</a:t>
             </a:r>
           </a:p>
         </p:txBody>
@@ -29167,7 +29167,7 @@
                 <a:ea typeface="Calibri"/>
                 <a:cs typeface="Calibri"/>
               </a:rPr>
-              <a:t>Every admitted database dispatched on every question. The result replicates on the five dev databases and on gpt-6-luna (−49.9% requests, 93 vs. 91 correct).</a:t>
+              <a:t>Every admitted database dispatched on every completed question. The result replicates on the five dev databases and on gpt-6-luna (−49.6% requests; 93 vs. 91 of 150).</a:t>
             </a:r>
           </a:p>
         </p:txBody>
@@ -29845,7 +29845,7 @@
                 <a:ea typeface="Calibri"/>
                 <a:cs typeface="Calibri"/>
               </a:rPr>
-              <a:t>On 924 held-out questions with a compiled agent (26 databases, two model families), dispatch was complete and no run showed a detected accuracy loss: requests fell 45–50%, latency 29–38%, and cost 11–18% at uncached prices. A hand-written schema prefetch matches the compiled program.</a:t>
+              <a:t>On 930 scheduled held-out questions with a compiled agent (26 databases, two model families), no run showed a detected accuracy loss, though equivalence is not established: requests fell 45–50%, latency 29–38%, and cost 11–18% at uncached prices. A hand-written schema prefetch matches the compiled program.</a:t>
             </a:r>
           </a:p>
         </p:txBody>

</xml_diff>